<commit_message>
Story 2.3: Edit Draft Metadata and Category DONE
</commit_message>
<xml_diff>
--- a/bmad-evolution.pptx
+++ b/bmad-evolution.pptx
@@ -6,17 +6,23 @@
   </p:sldMasterIdLst>
   <p:sldIdLst>
     <p:sldId id="256" r:id="rId2"/>
-    <p:sldId id="257" r:id="rId3"/>
-    <p:sldId id="258" r:id="rId4"/>
-    <p:sldId id="259" r:id="rId5"/>
-    <p:sldId id="260" r:id="rId6"/>
-    <p:sldId id="261" r:id="rId7"/>
-    <p:sldId id="262" r:id="rId8"/>
-    <p:sldId id="263" r:id="rId9"/>
-    <p:sldId id="264" r:id="rId10"/>
-    <p:sldId id="265" r:id="rId11"/>
-    <p:sldId id="266" r:id="rId12"/>
-    <p:sldId id="267" r:id="rId13"/>
+    <p:sldId id="268" r:id="rId3"/>
+    <p:sldId id="269" r:id="rId4"/>
+    <p:sldId id="270" r:id="rId5"/>
+    <p:sldId id="271" r:id="rId6"/>
+    <p:sldId id="272" r:id="rId7"/>
+    <p:sldId id="273" r:id="rId8"/>
+    <p:sldId id="257" r:id="rId9"/>
+    <p:sldId id="259" r:id="rId10"/>
+    <p:sldId id="258" r:id="rId11"/>
+    <p:sldId id="260" r:id="rId12"/>
+    <p:sldId id="261" r:id="rId13"/>
+    <p:sldId id="262" r:id="rId14"/>
+    <p:sldId id="263" r:id="rId15"/>
+    <p:sldId id="264" r:id="rId16"/>
+    <p:sldId id="265" r:id="rId17"/>
+    <p:sldId id="266" r:id="rId18"/>
+    <p:sldId id="267" r:id="rId19"/>
   </p:sldIdLst>
   <p:sldSz cx="12192000" cy="6858000"/>
   <p:notesSz cx="6858000" cy="9144000"/>
@@ -3353,6 +3359,612 @@
         <p:cNvPr id="1" name="">
           <a:extLst>
             <a:ext uri="{FF2B5EF4-FFF2-40B4-BE49-F238E27FC236}">
+              <a16:creationId xmlns:a16="http://schemas.microsoft.com/office/drawing/2014/main" id="{292521C4-58FD-4441-A521-E7BFF84A782F}"/>
+            </a:ext>
+          </a:extLst>
+        </p:cNvPr>
+        <p:cNvGrpSpPr/>
+        <p:nvPr/>
+      </p:nvGrpSpPr>
+      <p:grpSpPr>
+        <a:xfrm>
+          <a:off x="0" y="0"/>
+          <a:ext cx="0" cy="0"/>
+          <a:chOff x="0" y="0"/>
+          <a:chExt cx="0" cy="0"/>
+        </a:xfrm>
+      </p:grpSpPr>
+      <p:pic>
+        <p:nvPicPr>
+          <p:cNvPr id="2" name="Picture 1">
+            <a:extLst>
+              <a:ext uri="{FF2B5EF4-FFF2-40B4-BE49-F238E27FC236}">
+                <a16:creationId xmlns:a16="http://schemas.microsoft.com/office/drawing/2014/main" id="{5E705368-2371-E649-B1BC-29FE310AB975}"/>
+              </a:ext>
+            </a:extLst>
+          </p:cNvPr>
+          <p:cNvPicPr>
+            <a:picLocks noChangeAspect="1"/>
+          </p:cNvPicPr>
+          <p:nvPr/>
+        </p:nvPicPr>
+        <p:blipFill>
+          <a:blip r:embed="rId2"/>
+          <a:stretch>
+            <a:fillRect/>
+          </a:stretch>
+        </p:blipFill>
+        <p:spPr>
+          <a:xfrm>
+            <a:off x="2209800" y="1572373"/>
+            <a:ext cx="7772400" cy="3713253"/>
+          </a:xfrm>
+          <a:prstGeom prst="rect">
+            <a:avLst/>
+          </a:prstGeom>
+        </p:spPr>
+      </p:pic>
+    </p:spTree>
+    <p:extLst>
+      <p:ext uri="{BB962C8B-B14F-4D97-AF65-F5344CB8AC3E}">
+        <p14:creationId xmlns:p14="http://schemas.microsoft.com/office/powerpoint/2010/main" val="1876954945"/>
+      </p:ext>
+    </p:extLst>
+  </p:cSld>
+  <p:clrMapOvr>
+    <a:masterClrMapping/>
+  </p:clrMapOvr>
+</p:sld>
+</file>
+
+<file path=ppt/slides/slide11.xml><?xml version="1.0" encoding="utf-8"?>
+<p:sld xmlns:a="http://schemas.openxmlformats.org/drawingml/2006/main" xmlns:r="http://schemas.openxmlformats.org/officeDocument/2006/relationships" xmlns:p="http://schemas.openxmlformats.org/presentationml/2006/main">
+  <p:cSld>
+    <p:spTree>
+      <p:nvGrpSpPr>
+        <p:cNvPr id="1" name="">
+          <a:extLst>
+            <a:ext uri="{FF2B5EF4-FFF2-40B4-BE49-F238E27FC236}">
+              <a16:creationId xmlns:a16="http://schemas.microsoft.com/office/drawing/2014/main" id="{15F87219-D3AD-16E6-36E0-6B5414A283D9}"/>
+            </a:ext>
+          </a:extLst>
+        </p:cNvPr>
+        <p:cNvGrpSpPr/>
+        <p:nvPr/>
+      </p:nvGrpSpPr>
+      <p:grpSpPr>
+        <a:xfrm>
+          <a:off x="0" y="0"/>
+          <a:ext cx="0" cy="0"/>
+          <a:chOff x="0" y="0"/>
+          <a:chExt cx="0" cy="0"/>
+        </a:xfrm>
+      </p:grpSpPr>
+      <p:pic>
+        <p:nvPicPr>
+          <p:cNvPr id="2" name="Picture 1">
+            <a:extLst>
+              <a:ext uri="{FF2B5EF4-FFF2-40B4-BE49-F238E27FC236}">
+                <a16:creationId xmlns:a16="http://schemas.microsoft.com/office/drawing/2014/main" id="{46F46C73-B9C7-FA85-88BD-6C26C9EECEB5}"/>
+              </a:ext>
+            </a:extLst>
+          </p:cNvPr>
+          <p:cNvPicPr>
+            <a:picLocks noChangeAspect="1"/>
+          </p:cNvPicPr>
+          <p:nvPr/>
+        </p:nvPicPr>
+        <p:blipFill>
+          <a:blip r:embed="rId2"/>
+          <a:stretch>
+            <a:fillRect/>
+          </a:stretch>
+        </p:blipFill>
+        <p:spPr>
+          <a:xfrm>
+            <a:off x="3502041" y="0"/>
+            <a:ext cx="5187917" cy="6858000"/>
+          </a:xfrm>
+          <a:prstGeom prst="rect">
+            <a:avLst/>
+          </a:prstGeom>
+        </p:spPr>
+      </p:pic>
+      <p:pic>
+        <p:nvPicPr>
+          <p:cNvPr id="3" name="Picture 2">
+            <a:extLst>
+              <a:ext uri="{FF2B5EF4-FFF2-40B4-BE49-F238E27FC236}">
+                <a16:creationId xmlns:a16="http://schemas.microsoft.com/office/drawing/2014/main" id="{95437405-559F-EF1E-8A9A-CA51F4B38788}"/>
+              </a:ext>
+            </a:extLst>
+          </p:cNvPr>
+          <p:cNvPicPr>
+            <a:picLocks noChangeAspect="1"/>
+          </p:cNvPicPr>
+          <p:nvPr/>
+        </p:nvPicPr>
+        <p:blipFill>
+          <a:blip r:embed="rId3"/>
+          <a:stretch>
+            <a:fillRect/>
+          </a:stretch>
+        </p:blipFill>
+        <p:spPr>
+          <a:xfrm>
+            <a:off x="1677692" y="1584486"/>
+            <a:ext cx="5334000" cy="3937000"/>
+          </a:xfrm>
+          <a:prstGeom prst="rect">
+            <a:avLst/>
+          </a:prstGeom>
+        </p:spPr>
+      </p:pic>
+      <p:pic>
+        <p:nvPicPr>
+          <p:cNvPr id="4" name="Picture 3">
+            <a:extLst>
+              <a:ext uri="{FF2B5EF4-FFF2-40B4-BE49-F238E27FC236}">
+                <a16:creationId xmlns:a16="http://schemas.microsoft.com/office/drawing/2014/main" id="{271E81B1-1899-C88D-C8C6-10FBA603C4D9}"/>
+              </a:ext>
+            </a:extLst>
+          </p:cNvPr>
+          <p:cNvPicPr>
+            <a:picLocks noChangeAspect="1"/>
+          </p:cNvPicPr>
+          <p:nvPr/>
+        </p:nvPicPr>
+        <p:blipFill>
+          <a:blip r:embed="rId4"/>
+          <a:stretch>
+            <a:fillRect/>
+          </a:stretch>
+        </p:blipFill>
+        <p:spPr>
+          <a:xfrm>
+            <a:off x="5870629" y="716581"/>
+            <a:ext cx="5410200" cy="3937000"/>
+          </a:xfrm>
+          <a:prstGeom prst="rect">
+            <a:avLst/>
+          </a:prstGeom>
+        </p:spPr>
+      </p:pic>
+      <p:pic>
+        <p:nvPicPr>
+          <p:cNvPr id="6" name="Picture 5">
+            <a:extLst>
+              <a:ext uri="{FF2B5EF4-FFF2-40B4-BE49-F238E27FC236}">
+                <a16:creationId xmlns:a16="http://schemas.microsoft.com/office/drawing/2014/main" id="{5C32F8C1-28D0-25BA-2B5C-DD5704D743B9}"/>
+              </a:ext>
+            </a:extLst>
+          </p:cNvPr>
+          <p:cNvPicPr>
+            <a:picLocks noChangeAspect="1"/>
+          </p:cNvPicPr>
+          <p:nvPr/>
+        </p:nvPicPr>
+        <p:blipFill>
+          <a:blip r:embed="rId5"/>
+          <a:stretch>
+            <a:fillRect/>
+          </a:stretch>
+        </p:blipFill>
+        <p:spPr>
+          <a:xfrm>
+            <a:off x="3435350" y="514350"/>
+            <a:ext cx="5321300" cy="5829300"/>
+          </a:xfrm>
+          <a:prstGeom prst="rect">
+            <a:avLst/>
+          </a:prstGeom>
+        </p:spPr>
+      </p:pic>
+      <p:pic>
+        <p:nvPicPr>
+          <p:cNvPr id="7" name="Picture 6">
+            <a:extLst>
+              <a:ext uri="{FF2B5EF4-FFF2-40B4-BE49-F238E27FC236}">
+                <a16:creationId xmlns:a16="http://schemas.microsoft.com/office/drawing/2014/main" id="{7A2CD791-BF33-40F8-1EB8-8A45ABA64413}"/>
+              </a:ext>
+            </a:extLst>
+          </p:cNvPr>
+          <p:cNvPicPr>
+            <a:picLocks noChangeAspect="1"/>
+          </p:cNvPicPr>
+          <p:nvPr/>
+        </p:nvPicPr>
+        <p:blipFill>
+          <a:blip r:embed="rId6"/>
+          <a:stretch>
+            <a:fillRect/>
+          </a:stretch>
+        </p:blipFill>
+        <p:spPr>
+          <a:xfrm>
+            <a:off x="3473450" y="2152650"/>
+            <a:ext cx="5245100" cy="2552700"/>
+          </a:xfrm>
+          <a:prstGeom prst="rect">
+            <a:avLst/>
+          </a:prstGeom>
+        </p:spPr>
+      </p:pic>
+      <p:pic>
+        <p:nvPicPr>
+          <p:cNvPr id="8" name="Picture 7">
+            <a:extLst>
+              <a:ext uri="{FF2B5EF4-FFF2-40B4-BE49-F238E27FC236}">
+                <a16:creationId xmlns:a16="http://schemas.microsoft.com/office/drawing/2014/main" id="{879E01D5-95BC-5A8F-0899-E0BE52A95323}"/>
+              </a:ext>
+            </a:extLst>
+          </p:cNvPr>
+          <p:cNvPicPr>
+            <a:picLocks noChangeAspect="1"/>
+          </p:cNvPicPr>
+          <p:nvPr/>
+        </p:nvPicPr>
+        <p:blipFill>
+          <a:blip r:embed="rId7"/>
+          <a:stretch>
+            <a:fillRect/>
+          </a:stretch>
+        </p:blipFill>
+        <p:spPr>
+          <a:xfrm>
+            <a:off x="3340100" y="1555750"/>
+            <a:ext cx="5511800" cy="3746500"/>
+          </a:xfrm>
+          <a:prstGeom prst="rect">
+            <a:avLst/>
+          </a:prstGeom>
+        </p:spPr>
+      </p:pic>
+      <p:pic>
+        <p:nvPicPr>
+          <p:cNvPr id="9" name="Picture 8">
+            <a:extLst>
+              <a:ext uri="{FF2B5EF4-FFF2-40B4-BE49-F238E27FC236}">
+                <a16:creationId xmlns:a16="http://schemas.microsoft.com/office/drawing/2014/main" id="{9F8F8606-D9C2-4E13-0D8A-D71B8573A8F3}"/>
+              </a:ext>
+            </a:extLst>
+          </p:cNvPr>
+          <p:cNvPicPr>
+            <a:picLocks noChangeAspect="1"/>
+          </p:cNvPicPr>
+          <p:nvPr/>
+        </p:nvPicPr>
+        <p:blipFill>
+          <a:blip r:embed="rId8"/>
+          <a:stretch>
+            <a:fillRect/>
+          </a:stretch>
+        </p:blipFill>
+        <p:spPr>
+          <a:xfrm>
+            <a:off x="3416300" y="1816100"/>
+            <a:ext cx="5359400" cy="3225800"/>
+          </a:xfrm>
+          <a:prstGeom prst="rect">
+            <a:avLst/>
+          </a:prstGeom>
+        </p:spPr>
+      </p:pic>
+      <p:pic>
+        <p:nvPicPr>
+          <p:cNvPr id="10" name="Picture 9">
+            <a:extLst>
+              <a:ext uri="{FF2B5EF4-FFF2-40B4-BE49-F238E27FC236}">
+                <a16:creationId xmlns:a16="http://schemas.microsoft.com/office/drawing/2014/main" id="{9A0754EA-5FCF-A7E6-AF44-1FAC53F4E24C}"/>
+              </a:ext>
+            </a:extLst>
+          </p:cNvPr>
+          <p:cNvPicPr>
+            <a:picLocks noChangeAspect="1"/>
+          </p:cNvPicPr>
+          <p:nvPr/>
+        </p:nvPicPr>
+        <p:blipFill>
+          <a:blip r:embed="rId9"/>
+          <a:stretch>
+            <a:fillRect/>
+          </a:stretch>
+        </p:blipFill>
+        <p:spPr>
+          <a:xfrm>
+            <a:off x="3974969" y="0"/>
+            <a:ext cx="4242062" cy="6858000"/>
+          </a:xfrm>
+          <a:prstGeom prst="rect">
+            <a:avLst/>
+          </a:prstGeom>
+        </p:spPr>
+      </p:pic>
+      <p:pic>
+        <p:nvPicPr>
+          <p:cNvPr id="11" name="Picture 10">
+            <a:extLst>
+              <a:ext uri="{FF2B5EF4-FFF2-40B4-BE49-F238E27FC236}">
+                <a16:creationId xmlns:a16="http://schemas.microsoft.com/office/drawing/2014/main" id="{C792C674-9330-7344-B7AF-7F7B452C603A}"/>
+              </a:ext>
+            </a:extLst>
+          </p:cNvPr>
+          <p:cNvPicPr>
+            <a:picLocks noChangeAspect="1"/>
+          </p:cNvPicPr>
+          <p:nvPr/>
+        </p:nvPicPr>
+        <p:blipFill>
+          <a:blip r:embed="rId10"/>
+          <a:stretch>
+            <a:fillRect/>
+          </a:stretch>
+        </p:blipFill>
+        <p:spPr>
+          <a:xfrm>
+            <a:off x="3685072" y="0"/>
+            <a:ext cx="4821856" cy="6858000"/>
+          </a:xfrm>
+          <a:prstGeom prst="rect">
+            <a:avLst/>
+          </a:prstGeom>
+        </p:spPr>
+      </p:pic>
+      <p:pic>
+        <p:nvPicPr>
+          <p:cNvPr id="12" name="Picture 11">
+            <a:extLst>
+              <a:ext uri="{FF2B5EF4-FFF2-40B4-BE49-F238E27FC236}">
+                <a16:creationId xmlns:a16="http://schemas.microsoft.com/office/drawing/2014/main" id="{D0AD3B73-5E01-086A-5A82-A5CAB5CA38F5}"/>
+              </a:ext>
+            </a:extLst>
+          </p:cNvPr>
+          <p:cNvPicPr>
+            <a:picLocks noChangeAspect="1"/>
+          </p:cNvPicPr>
+          <p:nvPr/>
+        </p:nvPicPr>
+        <p:blipFill>
+          <a:blip r:embed="rId11"/>
+          <a:stretch>
+            <a:fillRect/>
+          </a:stretch>
+        </p:blipFill>
+        <p:spPr>
+          <a:xfrm>
+            <a:off x="3127169" y="0"/>
+            <a:ext cx="5937662" cy="6858000"/>
+          </a:xfrm>
+          <a:prstGeom prst="rect">
+            <a:avLst/>
+          </a:prstGeom>
+        </p:spPr>
+      </p:pic>
+    </p:spTree>
+    <p:extLst>
+      <p:ext uri="{BB962C8B-B14F-4D97-AF65-F5344CB8AC3E}">
+        <p14:creationId xmlns:p14="http://schemas.microsoft.com/office/powerpoint/2010/main" val="741105088"/>
+      </p:ext>
+    </p:extLst>
+  </p:cSld>
+  <p:clrMapOvr>
+    <a:masterClrMapping/>
+  </p:clrMapOvr>
+</p:sld>
+</file>
+
+<file path=ppt/slides/slide12.xml><?xml version="1.0" encoding="utf-8"?>
+<p:sld xmlns:a="http://schemas.openxmlformats.org/drawingml/2006/main" xmlns:r="http://schemas.openxmlformats.org/officeDocument/2006/relationships" xmlns:p="http://schemas.openxmlformats.org/presentationml/2006/main">
+  <p:cSld>
+    <p:spTree>
+      <p:nvGrpSpPr>
+        <p:cNvPr id="1" name="">
+          <a:extLst>
+            <a:ext uri="{FF2B5EF4-FFF2-40B4-BE49-F238E27FC236}">
+              <a16:creationId xmlns:a16="http://schemas.microsoft.com/office/drawing/2014/main" id="{6687C985-667C-1FDC-A85F-9360DEEF1E96}"/>
+            </a:ext>
+          </a:extLst>
+        </p:cNvPr>
+        <p:cNvGrpSpPr/>
+        <p:nvPr/>
+      </p:nvGrpSpPr>
+      <p:grpSpPr>
+        <a:xfrm>
+          <a:off x="0" y="0"/>
+          <a:ext cx="0" cy="0"/>
+          <a:chOff x="0" y="0"/>
+          <a:chExt cx="0" cy="0"/>
+        </a:xfrm>
+      </p:grpSpPr>
+      <p:pic>
+        <p:nvPicPr>
+          <p:cNvPr id="2" name="Picture 1">
+            <a:extLst>
+              <a:ext uri="{FF2B5EF4-FFF2-40B4-BE49-F238E27FC236}">
+                <a16:creationId xmlns:a16="http://schemas.microsoft.com/office/drawing/2014/main" id="{A48B870D-5873-030B-51FA-2BA5E7ECD9C3}"/>
+              </a:ext>
+            </a:extLst>
+          </p:cNvPr>
+          <p:cNvPicPr>
+            <a:picLocks noChangeAspect="1"/>
+          </p:cNvPicPr>
+          <p:nvPr/>
+        </p:nvPicPr>
+        <p:blipFill>
+          <a:blip r:embed="rId2"/>
+          <a:stretch>
+            <a:fillRect/>
+          </a:stretch>
+        </p:blipFill>
+        <p:spPr>
+          <a:xfrm>
+            <a:off x="2209800" y="1720548"/>
+            <a:ext cx="7772400" cy="3416903"/>
+          </a:xfrm>
+          <a:prstGeom prst="rect">
+            <a:avLst/>
+          </a:prstGeom>
+        </p:spPr>
+      </p:pic>
+      <p:pic>
+        <p:nvPicPr>
+          <p:cNvPr id="3" name="Picture 2">
+            <a:extLst>
+              <a:ext uri="{FF2B5EF4-FFF2-40B4-BE49-F238E27FC236}">
+                <a16:creationId xmlns:a16="http://schemas.microsoft.com/office/drawing/2014/main" id="{402FEA1A-503E-A6AC-5A5F-695F956B53B9}"/>
+              </a:ext>
+            </a:extLst>
+          </p:cNvPr>
+          <p:cNvPicPr>
+            <a:picLocks noChangeAspect="1"/>
+          </p:cNvPicPr>
+          <p:nvPr/>
+        </p:nvPicPr>
+        <p:blipFill>
+          <a:blip r:embed="rId3"/>
+          <a:stretch>
+            <a:fillRect/>
+          </a:stretch>
+        </p:blipFill>
+        <p:spPr>
+          <a:xfrm>
+            <a:off x="2209800" y="1575582"/>
+            <a:ext cx="7772400" cy="3706836"/>
+          </a:xfrm>
+          <a:prstGeom prst="rect">
+            <a:avLst/>
+          </a:prstGeom>
+        </p:spPr>
+      </p:pic>
+    </p:spTree>
+    <p:extLst>
+      <p:ext uri="{BB962C8B-B14F-4D97-AF65-F5344CB8AC3E}">
+        <p14:creationId xmlns:p14="http://schemas.microsoft.com/office/powerpoint/2010/main" val="1074857798"/>
+      </p:ext>
+    </p:extLst>
+  </p:cSld>
+  <p:clrMapOvr>
+    <a:masterClrMapping/>
+  </p:clrMapOvr>
+</p:sld>
+</file>
+
+<file path=ppt/slides/slide13.xml><?xml version="1.0" encoding="utf-8"?>
+<p:sld xmlns:a="http://schemas.openxmlformats.org/drawingml/2006/main" xmlns:r="http://schemas.openxmlformats.org/officeDocument/2006/relationships" xmlns:p="http://schemas.openxmlformats.org/presentationml/2006/main">
+  <p:cSld>
+    <p:spTree>
+      <p:nvGrpSpPr>
+        <p:cNvPr id="1" name="">
+          <a:extLst>
+            <a:ext uri="{FF2B5EF4-FFF2-40B4-BE49-F238E27FC236}">
+              <a16:creationId xmlns:a16="http://schemas.microsoft.com/office/drawing/2014/main" id="{D19F73BF-45E9-C55E-9904-BDF1C21F31D3}"/>
+            </a:ext>
+          </a:extLst>
+        </p:cNvPr>
+        <p:cNvGrpSpPr/>
+        <p:nvPr/>
+      </p:nvGrpSpPr>
+      <p:grpSpPr>
+        <a:xfrm>
+          <a:off x="0" y="0"/>
+          <a:ext cx="0" cy="0"/>
+          <a:chOff x="0" y="0"/>
+          <a:chExt cx="0" cy="0"/>
+        </a:xfrm>
+      </p:grpSpPr>
+    </p:spTree>
+    <p:extLst>
+      <p:ext uri="{BB962C8B-B14F-4D97-AF65-F5344CB8AC3E}">
+        <p14:creationId xmlns:p14="http://schemas.microsoft.com/office/powerpoint/2010/main" val="4235883773"/>
+      </p:ext>
+    </p:extLst>
+  </p:cSld>
+  <p:clrMapOvr>
+    <a:masterClrMapping/>
+  </p:clrMapOvr>
+</p:sld>
+</file>
+
+<file path=ppt/slides/slide14.xml><?xml version="1.0" encoding="utf-8"?>
+<p:sld xmlns:a="http://schemas.openxmlformats.org/drawingml/2006/main" xmlns:r="http://schemas.openxmlformats.org/officeDocument/2006/relationships" xmlns:p="http://schemas.openxmlformats.org/presentationml/2006/main">
+  <p:cSld>
+    <p:spTree>
+      <p:nvGrpSpPr>
+        <p:cNvPr id="1" name="">
+          <a:extLst>
+            <a:ext uri="{FF2B5EF4-FFF2-40B4-BE49-F238E27FC236}">
+              <a16:creationId xmlns:a16="http://schemas.microsoft.com/office/drawing/2014/main" id="{8C9CAADE-0919-19A0-AAF5-FB01A4523706}"/>
+            </a:ext>
+          </a:extLst>
+        </p:cNvPr>
+        <p:cNvGrpSpPr/>
+        <p:nvPr/>
+      </p:nvGrpSpPr>
+      <p:grpSpPr>
+        <a:xfrm>
+          <a:off x="0" y="0"/>
+          <a:ext cx="0" cy="0"/>
+          <a:chOff x="0" y="0"/>
+          <a:chExt cx="0" cy="0"/>
+        </a:xfrm>
+      </p:grpSpPr>
+    </p:spTree>
+    <p:extLst>
+      <p:ext uri="{BB962C8B-B14F-4D97-AF65-F5344CB8AC3E}">
+        <p14:creationId xmlns:p14="http://schemas.microsoft.com/office/powerpoint/2010/main" val="2060788727"/>
+      </p:ext>
+    </p:extLst>
+  </p:cSld>
+  <p:clrMapOvr>
+    <a:masterClrMapping/>
+  </p:clrMapOvr>
+</p:sld>
+</file>
+
+<file path=ppt/slides/slide15.xml><?xml version="1.0" encoding="utf-8"?>
+<p:sld xmlns:a="http://schemas.openxmlformats.org/drawingml/2006/main" xmlns:r="http://schemas.openxmlformats.org/officeDocument/2006/relationships" xmlns:p="http://schemas.openxmlformats.org/presentationml/2006/main">
+  <p:cSld>
+    <p:spTree>
+      <p:nvGrpSpPr>
+        <p:cNvPr id="1" name="">
+          <a:extLst>
+            <a:ext uri="{FF2B5EF4-FFF2-40B4-BE49-F238E27FC236}">
+              <a16:creationId xmlns:a16="http://schemas.microsoft.com/office/drawing/2014/main" id="{7E38F23A-D6C9-B974-5B29-14986B854CAF}"/>
+            </a:ext>
+          </a:extLst>
+        </p:cNvPr>
+        <p:cNvGrpSpPr/>
+        <p:nvPr/>
+      </p:nvGrpSpPr>
+      <p:grpSpPr>
+        <a:xfrm>
+          <a:off x="0" y="0"/>
+          <a:ext cx="0" cy="0"/>
+          <a:chOff x="0" y="0"/>
+          <a:chExt cx="0" cy="0"/>
+        </a:xfrm>
+      </p:grpSpPr>
+    </p:spTree>
+    <p:extLst>
+      <p:ext uri="{BB962C8B-B14F-4D97-AF65-F5344CB8AC3E}">
+        <p14:creationId xmlns:p14="http://schemas.microsoft.com/office/powerpoint/2010/main" val="4169136817"/>
+      </p:ext>
+    </p:extLst>
+  </p:cSld>
+  <p:clrMapOvr>
+    <a:masterClrMapping/>
+  </p:clrMapOvr>
+</p:sld>
+</file>
+
+<file path=ppt/slides/slide16.xml><?xml version="1.0" encoding="utf-8"?>
+<p:sld xmlns:a="http://schemas.openxmlformats.org/drawingml/2006/main" xmlns:r="http://schemas.openxmlformats.org/officeDocument/2006/relationships" xmlns:p="http://schemas.openxmlformats.org/presentationml/2006/main">
+  <p:cSld>
+    <p:spTree>
+      <p:nvGrpSpPr>
+        <p:cNvPr id="1" name="">
+          <a:extLst>
+            <a:ext uri="{FF2B5EF4-FFF2-40B4-BE49-F238E27FC236}">
               <a16:creationId xmlns:a16="http://schemas.microsoft.com/office/drawing/2014/main" id="{1C5B03D0-4356-2EC2-0CF0-E414EB0385CA}"/>
             </a:ext>
           </a:extLst>
@@ -3381,7 +3993,7 @@
 </p:sld>
 </file>
 
-<file path=ppt/slides/slide11.xml><?xml version="1.0" encoding="utf-8"?>
+<file path=ppt/slides/slide17.xml><?xml version="1.0" encoding="utf-8"?>
 <p:sld xmlns:a="http://schemas.openxmlformats.org/drawingml/2006/main" xmlns:r="http://schemas.openxmlformats.org/officeDocument/2006/relationships" xmlns:p="http://schemas.openxmlformats.org/presentationml/2006/main">
   <p:cSld>
     <p:spTree>
@@ -3417,7 +4029,7 @@
 </p:sld>
 </file>
 
-<file path=ppt/slides/slide12.xml><?xml version="1.0" encoding="utf-8"?>
+<file path=ppt/slides/slide18.xml><?xml version="1.0" encoding="utf-8"?>
 <p:sld xmlns:a="http://schemas.openxmlformats.org/drawingml/2006/main" xmlns:r="http://schemas.openxmlformats.org/officeDocument/2006/relationships" xmlns:p="http://schemas.openxmlformats.org/presentationml/2006/main">
   <p:cSld>
     <p:spTree>
@@ -3461,7 +4073,193 @@
         <p:cNvPr id="1" name="">
           <a:extLst>
             <a:ext uri="{FF2B5EF4-FFF2-40B4-BE49-F238E27FC236}">
-              <a16:creationId xmlns:a16="http://schemas.microsoft.com/office/drawing/2014/main" id="{88101E74-77EE-E2B4-92D9-576F6C5847B8}"/>
+              <a16:creationId xmlns:a16="http://schemas.microsoft.com/office/drawing/2014/main" id="{8D0CC96B-BBE6-CD94-5FD5-925D5FD310A5}"/>
+            </a:ext>
+          </a:extLst>
+        </p:cNvPr>
+        <p:cNvGrpSpPr/>
+        <p:nvPr/>
+      </p:nvGrpSpPr>
+      <p:grpSpPr>
+        <a:xfrm>
+          <a:off x="0" y="0"/>
+          <a:ext cx="0" cy="0"/>
+          <a:chOff x="0" y="0"/>
+          <a:chExt cx="0" cy="0"/>
+        </a:xfrm>
+      </p:grpSpPr>
+      <p:pic>
+        <p:nvPicPr>
+          <p:cNvPr id="2" name="Picture 1">
+            <a:extLst>
+              <a:ext uri="{FF2B5EF4-FFF2-40B4-BE49-F238E27FC236}">
+                <a16:creationId xmlns:a16="http://schemas.microsoft.com/office/drawing/2014/main" id="{E289BA20-92D0-A7CC-DAAC-275D637C389C}"/>
+              </a:ext>
+            </a:extLst>
+          </p:cNvPr>
+          <p:cNvPicPr>
+            <a:picLocks noChangeAspect="1"/>
+          </p:cNvPicPr>
+          <p:nvPr/>
+        </p:nvPicPr>
+        <p:blipFill>
+          <a:blip r:embed="rId2"/>
+          <a:stretch>
+            <a:fillRect/>
+          </a:stretch>
+        </p:blipFill>
+        <p:spPr>
+          <a:xfrm>
+            <a:off x="4209188" y="0"/>
+            <a:ext cx="3773623" cy="6858000"/>
+          </a:xfrm>
+          <a:prstGeom prst="rect">
+            <a:avLst/>
+          </a:prstGeom>
+        </p:spPr>
+      </p:pic>
+      <p:pic>
+        <p:nvPicPr>
+          <p:cNvPr id="3" name="Picture 2">
+            <a:extLst>
+              <a:ext uri="{FF2B5EF4-FFF2-40B4-BE49-F238E27FC236}">
+                <a16:creationId xmlns:a16="http://schemas.microsoft.com/office/drawing/2014/main" id="{DCD71677-63A5-3021-2027-C3F200225F9E}"/>
+              </a:ext>
+            </a:extLst>
+          </p:cNvPr>
+          <p:cNvPicPr>
+            <a:picLocks noChangeAspect="1"/>
+          </p:cNvPicPr>
+          <p:nvPr/>
+        </p:nvPicPr>
+        <p:blipFill>
+          <a:blip r:embed="rId3"/>
+          <a:stretch>
+            <a:fillRect/>
+          </a:stretch>
+        </p:blipFill>
+        <p:spPr>
+          <a:xfrm>
+            <a:off x="6900179" y="0"/>
+            <a:ext cx="4033024" cy="6858000"/>
+          </a:xfrm>
+          <a:prstGeom prst="rect">
+            <a:avLst/>
+          </a:prstGeom>
+        </p:spPr>
+      </p:pic>
+      <p:pic>
+        <p:nvPicPr>
+          <p:cNvPr id="4" name="Picture 3">
+            <a:extLst>
+              <a:ext uri="{FF2B5EF4-FFF2-40B4-BE49-F238E27FC236}">
+                <a16:creationId xmlns:a16="http://schemas.microsoft.com/office/drawing/2014/main" id="{DD188B15-A404-F55B-624E-B9BE34906750}"/>
+              </a:ext>
+            </a:extLst>
+          </p:cNvPr>
+          <p:cNvPicPr>
+            <a:picLocks noChangeAspect="1"/>
+          </p:cNvPicPr>
+          <p:nvPr/>
+        </p:nvPicPr>
+        <p:blipFill>
+          <a:blip r:embed="rId4"/>
+          <a:stretch>
+            <a:fillRect/>
+          </a:stretch>
+        </p:blipFill>
+        <p:spPr>
+          <a:xfrm>
+            <a:off x="3314700" y="628650"/>
+            <a:ext cx="5562600" cy="5600700"/>
+          </a:xfrm>
+          <a:prstGeom prst="rect">
+            <a:avLst/>
+          </a:prstGeom>
+        </p:spPr>
+      </p:pic>
+      <p:pic>
+        <p:nvPicPr>
+          <p:cNvPr id="5" name="Picture 4">
+            <a:extLst>
+              <a:ext uri="{FF2B5EF4-FFF2-40B4-BE49-F238E27FC236}">
+                <a16:creationId xmlns:a16="http://schemas.microsoft.com/office/drawing/2014/main" id="{81155593-831B-5D21-A7A8-CBCA32F247FA}"/>
+              </a:ext>
+            </a:extLst>
+          </p:cNvPr>
+          <p:cNvPicPr>
+            <a:picLocks noChangeAspect="1"/>
+          </p:cNvPicPr>
+          <p:nvPr/>
+        </p:nvPicPr>
+        <p:blipFill>
+          <a:blip r:embed="rId5"/>
+          <a:stretch>
+            <a:fillRect/>
+          </a:stretch>
+        </p:blipFill>
+        <p:spPr>
+          <a:xfrm>
+            <a:off x="1027138" y="0"/>
+            <a:ext cx="5549900" cy="6235700"/>
+          </a:xfrm>
+          <a:prstGeom prst="rect">
+            <a:avLst/>
+          </a:prstGeom>
+        </p:spPr>
+      </p:pic>
+      <p:pic>
+        <p:nvPicPr>
+          <p:cNvPr id="6" name="Picture 5">
+            <a:extLst>
+              <a:ext uri="{FF2B5EF4-FFF2-40B4-BE49-F238E27FC236}">
+                <a16:creationId xmlns:a16="http://schemas.microsoft.com/office/drawing/2014/main" id="{4A1665A6-BF0E-467C-092E-E7F0C04FBE81}"/>
+              </a:ext>
+            </a:extLst>
+          </p:cNvPr>
+          <p:cNvPicPr>
+            <a:picLocks noChangeAspect="1"/>
+          </p:cNvPicPr>
+          <p:nvPr/>
+        </p:nvPicPr>
+        <p:blipFill>
+          <a:blip r:embed="rId6"/>
+          <a:stretch>
+            <a:fillRect/>
+          </a:stretch>
+        </p:blipFill>
+        <p:spPr>
+          <a:xfrm>
+            <a:off x="4035570" y="0"/>
+            <a:ext cx="4120860" cy="6858000"/>
+          </a:xfrm>
+          <a:prstGeom prst="rect">
+            <a:avLst/>
+          </a:prstGeom>
+        </p:spPr>
+      </p:pic>
+    </p:spTree>
+    <p:extLst>
+      <p:ext uri="{BB962C8B-B14F-4D97-AF65-F5344CB8AC3E}">
+        <p14:creationId xmlns:p14="http://schemas.microsoft.com/office/powerpoint/2010/main" val="1744299646"/>
+      </p:ext>
+    </p:extLst>
+  </p:cSld>
+  <p:clrMapOvr>
+    <a:masterClrMapping/>
+  </p:clrMapOvr>
+</p:sld>
+</file>
+
+<file path=ppt/slides/slide3.xml><?xml version="1.0" encoding="utf-8"?>
+<p:sld xmlns:a="http://schemas.openxmlformats.org/drawingml/2006/main" xmlns:r="http://schemas.openxmlformats.org/officeDocument/2006/relationships" xmlns:p="http://schemas.openxmlformats.org/presentationml/2006/main">
+  <p:cSld>
+    <p:spTree>
+      <p:nvGrpSpPr>
+        <p:cNvPr id="1" name="">
+          <a:extLst>
+            <a:ext uri="{FF2B5EF4-FFF2-40B4-BE49-F238E27FC236}">
+              <a16:creationId xmlns:a16="http://schemas.microsoft.com/office/drawing/2014/main" id="{2C9146FD-699C-7C86-18A0-03086974D17E}"/>
             </a:ext>
           </a:extLst>
         </p:cNvPr>
@@ -3479,7 +4277,7 @@
     </p:spTree>
     <p:extLst>
       <p:ext uri="{BB962C8B-B14F-4D97-AF65-F5344CB8AC3E}">
-        <p14:creationId xmlns:p14="http://schemas.microsoft.com/office/powerpoint/2010/main" val="1830232265"/>
+        <p14:creationId xmlns:p14="http://schemas.microsoft.com/office/powerpoint/2010/main" val="553819064"/>
       </p:ext>
     </p:extLst>
   </p:cSld>
@@ -3489,7 +4287,7 @@
 </p:sld>
 </file>
 
-<file path=ppt/slides/slide3.xml><?xml version="1.0" encoding="utf-8"?>
+<file path=ppt/slides/slide4.xml><?xml version="1.0" encoding="utf-8"?>
 <p:sld xmlns:a="http://schemas.openxmlformats.org/drawingml/2006/main" xmlns:r="http://schemas.openxmlformats.org/officeDocument/2006/relationships" xmlns:p="http://schemas.openxmlformats.org/presentationml/2006/main">
   <p:cSld>
     <p:spTree>
@@ -3497,7 +4295,151 @@
         <p:cNvPr id="1" name="">
           <a:extLst>
             <a:ext uri="{FF2B5EF4-FFF2-40B4-BE49-F238E27FC236}">
-              <a16:creationId xmlns:a16="http://schemas.microsoft.com/office/drawing/2014/main" id="{292521C4-58FD-4441-A521-E7BFF84A782F}"/>
+              <a16:creationId xmlns:a16="http://schemas.microsoft.com/office/drawing/2014/main" id="{0C91E45D-055A-8F03-0090-51D766EAE416}"/>
+            </a:ext>
+          </a:extLst>
+        </p:cNvPr>
+        <p:cNvGrpSpPr/>
+        <p:nvPr/>
+      </p:nvGrpSpPr>
+      <p:grpSpPr>
+        <a:xfrm>
+          <a:off x="0" y="0"/>
+          <a:ext cx="0" cy="0"/>
+          <a:chOff x="0" y="0"/>
+          <a:chExt cx="0" cy="0"/>
+        </a:xfrm>
+      </p:grpSpPr>
+    </p:spTree>
+    <p:extLst>
+      <p:ext uri="{BB962C8B-B14F-4D97-AF65-F5344CB8AC3E}">
+        <p14:creationId xmlns:p14="http://schemas.microsoft.com/office/powerpoint/2010/main" val="1619225517"/>
+      </p:ext>
+    </p:extLst>
+  </p:cSld>
+  <p:clrMapOvr>
+    <a:masterClrMapping/>
+  </p:clrMapOvr>
+</p:sld>
+</file>
+
+<file path=ppt/slides/slide5.xml><?xml version="1.0" encoding="utf-8"?>
+<p:sld xmlns:a="http://schemas.openxmlformats.org/drawingml/2006/main" xmlns:r="http://schemas.openxmlformats.org/officeDocument/2006/relationships" xmlns:p="http://schemas.openxmlformats.org/presentationml/2006/main">
+  <p:cSld>
+    <p:spTree>
+      <p:nvGrpSpPr>
+        <p:cNvPr id="1" name="">
+          <a:extLst>
+            <a:ext uri="{FF2B5EF4-FFF2-40B4-BE49-F238E27FC236}">
+              <a16:creationId xmlns:a16="http://schemas.microsoft.com/office/drawing/2014/main" id="{AF829FF7-4575-A967-77AE-67E11AD9291F}"/>
+            </a:ext>
+          </a:extLst>
+        </p:cNvPr>
+        <p:cNvGrpSpPr/>
+        <p:nvPr/>
+      </p:nvGrpSpPr>
+      <p:grpSpPr>
+        <a:xfrm>
+          <a:off x="0" y="0"/>
+          <a:ext cx="0" cy="0"/>
+          <a:chOff x="0" y="0"/>
+          <a:chExt cx="0" cy="0"/>
+        </a:xfrm>
+      </p:grpSpPr>
+    </p:spTree>
+    <p:extLst>
+      <p:ext uri="{BB962C8B-B14F-4D97-AF65-F5344CB8AC3E}">
+        <p14:creationId xmlns:p14="http://schemas.microsoft.com/office/powerpoint/2010/main" val="567333954"/>
+      </p:ext>
+    </p:extLst>
+  </p:cSld>
+  <p:clrMapOvr>
+    <a:masterClrMapping/>
+  </p:clrMapOvr>
+</p:sld>
+</file>
+
+<file path=ppt/slides/slide6.xml><?xml version="1.0" encoding="utf-8"?>
+<p:sld xmlns:a="http://schemas.openxmlformats.org/drawingml/2006/main" xmlns:r="http://schemas.openxmlformats.org/officeDocument/2006/relationships" xmlns:p="http://schemas.openxmlformats.org/presentationml/2006/main">
+  <p:cSld>
+    <p:spTree>
+      <p:nvGrpSpPr>
+        <p:cNvPr id="1" name="">
+          <a:extLst>
+            <a:ext uri="{FF2B5EF4-FFF2-40B4-BE49-F238E27FC236}">
+              <a16:creationId xmlns:a16="http://schemas.microsoft.com/office/drawing/2014/main" id="{B0F24B41-B631-F930-05D0-0EF6B963A909}"/>
+            </a:ext>
+          </a:extLst>
+        </p:cNvPr>
+        <p:cNvGrpSpPr/>
+        <p:nvPr/>
+      </p:nvGrpSpPr>
+      <p:grpSpPr>
+        <a:xfrm>
+          <a:off x="0" y="0"/>
+          <a:ext cx="0" cy="0"/>
+          <a:chOff x="0" y="0"/>
+          <a:chExt cx="0" cy="0"/>
+        </a:xfrm>
+      </p:grpSpPr>
+    </p:spTree>
+    <p:extLst>
+      <p:ext uri="{BB962C8B-B14F-4D97-AF65-F5344CB8AC3E}">
+        <p14:creationId xmlns:p14="http://schemas.microsoft.com/office/powerpoint/2010/main" val="3245717247"/>
+      </p:ext>
+    </p:extLst>
+  </p:cSld>
+  <p:clrMapOvr>
+    <a:masterClrMapping/>
+  </p:clrMapOvr>
+</p:sld>
+</file>
+
+<file path=ppt/slides/slide7.xml><?xml version="1.0" encoding="utf-8"?>
+<p:sld xmlns:a="http://schemas.openxmlformats.org/drawingml/2006/main" xmlns:r="http://schemas.openxmlformats.org/officeDocument/2006/relationships" xmlns:p="http://schemas.openxmlformats.org/presentationml/2006/main">
+  <p:cSld>
+    <p:spTree>
+      <p:nvGrpSpPr>
+        <p:cNvPr id="1" name="">
+          <a:extLst>
+            <a:ext uri="{FF2B5EF4-FFF2-40B4-BE49-F238E27FC236}">
+              <a16:creationId xmlns:a16="http://schemas.microsoft.com/office/drawing/2014/main" id="{87A5F92B-4A7D-8739-A6FD-DC5D952EFD83}"/>
+            </a:ext>
+          </a:extLst>
+        </p:cNvPr>
+        <p:cNvGrpSpPr/>
+        <p:nvPr/>
+      </p:nvGrpSpPr>
+      <p:grpSpPr>
+        <a:xfrm>
+          <a:off x="0" y="0"/>
+          <a:ext cx="0" cy="0"/>
+          <a:chOff x="0" y="0"/>
+          <a:chExt cx="0" cy="0"/>
+        </a:xfrm>
+      </p:grpSpPr>
+    </p:spTree>
+    <p:extLst>
+      <p:ext uri="{BB962C8B-B14F-4D97-AF65-F5344CB8AC3E}">
+        <p14:creationId xmlns:p14="http://schemas.microsoft.com/office/powerpoint/2010/main" val="566697227"/>
+      </p:ext>
+    </p:extLst>
+  </p:cSld>
+  <p:clrMapOvr>
+    <a:masterClrMapping/>
+  </p:clrMapOvr>
+</p:sld>
+</file>
+
+<file path=ppt/slides/slide8.xml><?xml version="1.0" encoding="utf-8"?>
+<p:sld xmlns:a="http://schemas.openxmlformats.org/drawingml/2006/main" xmlns:r="http://schemas.openxmlformats.org/officeDocument/2006/relationships" xmlns:p="http://schemas.openxmlformats.org/presentationml/2006/main">
+  <p:cSld>
+    <p:spTree>
+      <p:nvGrpSpPr>
+        <p:cNvPr id="1" name="">
+          <a:extLst>
+            <a:ext uri="{FF2B5EF4-FFF2-40B4-BE49-F238E27FC236}">
+              <a16:creationId xmlns:a16="http://schemas.microsoft.com/office/drawing/2014/main" id="{88101E74-77EE-E2B4-92D9-576F6C5847B8}"/>
             </a:ext>
           </a:extLst>
         </p:cNvPr>
@@ -3517,7 +4459,7 @@
           <p:cNvPr id="2" name="Picture 1">
             <a:extLst>
               <a:ext uri="{FF2B5EF4-FFF2-40B4-BE49-F238E27FC236}">
-                <a16:creationId xmlns:a16="http://schemas.microsoft.com/office/drawing/2014/main" id="{5E705368-2371-E649-B1BC-29FE310AB975}"/>
+                <a16:creationId xmlns:a16="http://schemas.microsoft.com/office/drawing/2014/main" id="{391E80B2-7C03-3C41-5E28-56EF34786EB3}"/>
               </a:ext>
             </a:extLst>
           </p:cNvPr>
@@ -3534,8 +4476,8 @@
         </p:blipFill>
         <p:spPr>
           <a:xfrm>
-            <a:off x="2209800" y="1572373"/>
-            <a:ext cx="7772400" cy="3713253"/>
+            <a:off x="2749550" y="673100"/>
+            <a:ext cx="6692900" cy="5511800"/>
           </a:xfrm>
           <a:prstGeom prst="rect">
             <a:avLst/>
@@ -3545,7 +4487,7 @@
     </p:spTree>
     <p:extLst>
       <p:ext uri="{BB962C8B-B14F-4D97-AF65-F5344CB8AC3E}">
-        <p14:creationId xmlns:p14="http://schemas.microsoft.com/office/powerpoint/2010/main" val="1876954945"/>
+        <p14:creationId xmlns:p14="http://schemas.microsoft.com/office/powerpoint/2010/main" val="1830232265"/>
       </p:ext>
     </p:extLst>
   </p:cSld>
@@ -3555,7 +4497,7 @@
 </p:sld>
 </file>
 
-<file path=ppt/slides/slide4.xml><?xml version="1.0" encoding="utf-8"?>
+<file path=ppt/slides/slide9.xml><?xml version="1.0" encoding="utf-8"?>
 <p:sld xmlns:a="http://schemas.openxmlformats.org/drawingml/2006/main" xmlns:r="http://schemas.openxmlformats.org/officeDocument/2006/relationships" xmlns:p="http://schemas.openxmlformats.org/presentationml/2006/main">
   <p:cSld>
     <p:spTree>
@@ -3578,190 +4520,70 @@
           <a:chExt cx="0" cy="0"/>
         </a:xfrm>
       </p:grpSpPr>
+      <p:pic>
+        <p:nvPicPr>
+          <p:cNvPr id="3" name="Picture 2">
+            <a:extLst>
+              <a:ext uri="{FF2B5EF4-FFF2-40B4-BE49-F238E27FC236}">
+                <a16:creationId xmlns:a16="http://schemas.microsoft.com/office/drawing/2014/main" id="{F5C31030-8435-EEAE-3757-0C060A6998C9}"/>
+              </a:ext>
+            </a:extLst>
+          </p:cNvPr>
+          <p:cNvPicPr>
+            <a:picLocks noChangeAspect="1"/>
+          </p:cNvPicPr>
+          <p:nvPr/>
+        </p:nvPicPr>
+        <p:blipFill>
+          <a:blip r:embed="rId2"/>
+          <a:stretch>
+            <a:fillRect/>
+          </a:stretch>
+        </p:blipFill>
+        <p:spPr>
+          <a:xfrm>
+            <a:off x="2209800" y="2774950"/>
+            <a:ext cx="5632342" cy="1192616"/>
+          </a:xfrm>
+          <a:prstGeom prst="rect">
+            <a:avLst/>
+          </a:prstGeom>
+        </p:spPr>
+      </p:pic>
+      <p:pic>
+        <p:nvPicPr>
+          <p:cNvPr id="5" name="Picture 4">
+            <a:extLst>
+              <a:ext uri="{FF2B5EF4-FFF2-40B4-BE49-F238E27FC236}">
+                <a16:creationId xmlns:a16="http://schemas.microsoft.com/office/drawing/2014/main" id="{1333B22B-F2CA-7C56-AD4F-765066EF2E53}"/>
+              </a:ext>
+            </a:extLst>
+          </p:cNvPr>
+          <p:cNvPicPr>
+            <a:picLocks noChangeAspect="1"/>
+          </p:cNvPicPr>
+          <p:nvPr/>
+        </p:nvPicPr>
+        <p:blipFill>
+          <a:blip r:embed="rId3"/>
+          <a:stretch>
+            <a:fillRect/>
+          </a:stretch>
+        </p:blipFill>
+        <p:spPr>
+          <a:xfrm>
+            <a:off x="1476859" y="1732958"/>
+            <a:ext cx="5626100" cy="1638300"/>
+          </a:xfrm>
+          <a:prstGeom prst="rect">
+            <a:avLst/>
+          </a:prstGeom>
+        </p:spPr>
+      </p:pic>
     </p:spTree>
     <p:extLst>
       <p:ext uri="{BB962C8B-B14F-4D97-AF65-F5344CB8AC3E}">
         <p14:creationId xmlns:p14="http://schemas.microsoft.com/office/powerpoint/2010/main" val="742561166"/>
-      </p:ext>
-    </p:extLst>
-  </p:cSld>
-  <p:clrMapOvr>
-    <a:masterClrMapping/>
-  </p:clrMapOvr>
-</p:sld>
-</file>
-
-<file path=ppt/slides/slide5.xml><?xml version="1.0" encoding="utf-8"?>
-<p:sld xmlns:a="http://schemas.openxmlformats.org/drawingml/2006/main" xmlns:r="http://schemas.openxmlformats.org/officeDocument/2006/relationships" xmlns:p="http://schemas.openxmlformats.org/presentationml/2006/main">
-  <p:cSld>
-    <p:spTree>
-      <p:nvGrpSpPr>
-        <p:cNvPr id="1" name="">
-          <a:extLst>
-            <a:ext uri="{FF2B5EF4-FFF2-40B4-BE49-F238E27FC236}">
-              <a16:creationId xmlns:a16="http://schemas.microsoft.com/office/drawing/2014/main" id="{15F87219-D3AD-16E6-36E0-6B5414A283D9}"/>
-            </a:ext>
-          </a:extLst>
-        </p:cNvPr>
-        <p:cNvGrpSpPr/>
-        <p:nvPr/>
-      </p:nvGrpSpPr>
-      <p:grpSpPr>
-        <a:xfrm>
-          <a:off x="0" y="0"/>
-          <a:ext cx="0" cy="0"/>
-          <a:chOff x="0" y="0"/>
-          <a:chExt cx="0" cy="0"/>
-        </a:xfrm>
-      </p:grpSpPr>
-    </p:spTree>
-    <p:extLst>
-      <p:ext uri="{BB962C8B-B14F-4D97-AF65-F5344CB8AC3E}">
-        <p14:creationId xmlns:p14="http://schemas.microsoft.com/office/powerpoint/2010/main" val="741105088"/>
-      </p:ext>
-    </p:extLst>
-  </p:cSld>
-  <p:clrMapOvr>
-    <a:masterClrMapping/>
-  </p:clrMapOvr>
-</p:sld>
-</file>
-
-<file path=ppt/slides/slide6.xml><?xml version="1.0" encoding="utf-8"?>
-<p:sld xmlns:a="http://schemas.openxmlformats.org/drawingml/2006/main" xmlns:r="http://schemas.openxmlformats.org/officeDocument/2006/relationships" xmlns:p="http://schemas.openxmlformats.org/presentationml/2006/main">
-  <p:cSld>
-    <p:spTree>
-      <p:nvGrpSpPr>
-        <p:cNvPr id="1" name="">
-          <a:extLst>
-            <a:ext uri="{FF2B5EF4-FFF2-40B4-BE49-F238E27FC236}">
-              <a16:creationId xmlns:a16="http://schemas.microsoft.com/office/drawing/2014/main" id="{6687C985-667C-1FDC-A85F-9360DEEF1E96}"/>
-            </a:ext>
-          </a:extLst>
-        </p:cNvPr>
-        <p:cNvGrpSpPr/>
-        <p:nvPr/>
-      </p:nvGrpSpPr>
-      <p:grpSpPr>
-        <a:xfrm>
-          <a:off x="0" y="0"/>
-          <a:ext cx="0" cy="0"/>
-          <a:chOff x="0" y="0"/>
-          <a:chExt cx="0" cy="0"/>
-        </a:xfrm>
-      </p:grpSpPr>
-    </p:spTree>
-    <p:extLst>
-      <p:ext uri="{BB962C8B-B14F-4D97-AF65-F5344CB8AC3E}">
-        <p14:creationId xmlns:p14="http://schemas.microsoft.com/office/powerpoint/2010/main" val="1074857798"/>
-      </p:ext>
-    </p:extLst>
-  </p:cSld>
-  <p:clrMapOvr>
-    <a:masterClrMapping/>
-  </p:clrMapOvr>
-</p:sld>
-</file>
-
-<file path=ppt/slides/slide7.xml><?xml version="1.0" encoding="utf-8"?>
-<p:sld xmlns:a="http://schemas.openxmlformats.org/drawingml/2006/main" xmlns:r="http://schemas.openxmlformats.org/officeDocument/2006/relationships" xmlns:p="http://schemas.openxmlformats.org/presentationml/2006/main">
-  <p:cSld>
-    <p:spTree>
-      <p:nvGrpSpPr>
-        <p:cNvPr id="1" name="">
-          <a:extLst>
-            <a:ext uri="{FF2B5EF4-FFF2-40B4-BE49-F238E27FC236}">
-              <a16:creationId xmlns:a16="http://schemas.microsoft.com/office/drawing/2014/main" id="{D19F73BF-45E9-C55E-9904-BDF1C21F31D3}"/>
-            </a:ext>
-          </a:extLst>
-        </p:cNvPr>
-        <p:cNvGrpSpPr/>
-        <p:nvPr/>
-      </p:nvGrpSpPr>
-      <p:grpSpPr>
-        <a:xfrm>
-          <a:off x="0" y="0"/>
-          <a:ext cx="0" cy="0"/>
-          <a:chOff x="0" y="0"/>
-          <a:chExt cx="0" cy="0"/>
-        </a:xfrm>
-      </p:grpSpPr>
-    </p:spTree>
-    <p:extLst>
-      <p:ext uri="{BB962C8B-B14F-4D97-AF65-F5344CB8AC3E}">
-        <p14:creationId xmlns:p14="http://schemas.microsoft.com/office/powerpoint/2010/main" val="4235883773"/>
-      </p:ext>
-    </p:extLst>
-  </p:cSld>
-  <p:clrMapOvr>
-    <a:masterClrMapping/>
-  </p:clrMapOvr>
-</p:sld>
-</file>
-
-<file path=ppt/slides/slide8.xml><?xml version="1.0" encoding="utf-8"?>
-<p:sld xmlns:a="http://schemas.openxmlformats.org/drawingml/2006/main" xmlns:r="http://schemas.openxmlformats.org/officeDocument/2006/relationships" xmlns:p="http://schemas.openxmlformats.org/presentationml/2006/main">
-  <p:cSld>
-    <p:spTree>
-      <p:nvGrpSpPr>
-        <p:cNvPr id="1" name="">
-          <a:extLst>
-            <a:ext uri="{FF2B5EF4-FFF2-40B4-BE49-F238E27FC236}">
-              <a16:creationId xmlns:a16="http://schemas.microsoft.com/office/drawing/2014/main" id="{8C9CAADE-0919-19A0-AAF5-FB01A4523706}"/>
-            </a:ext>
-          </a:extLst>
-        </p:cNvPr>
-        <p:cNvGrpSpPr/>
-        <p:nvPr/>
-      </p:nvGrpSpPr>
-      <p:grpSpPr>
-        <a:xfrm>
-          <a:off x="0" y="0"/>
-          <a:ext cx="0" cy="0"/>
-          <a:chOff x="0" y="0"/>
-          <a:chExt cx="0" cy="0"/>
-        </a:xfrm>
-      </p:grpSpPr>
-    </p:spTree>
-    <p:extLst>
-      <p:ext uri="{BB962C8B-B14F-4D97-AF65-F5344CB8AC3E}">
-        <p14:creationId xmlns:p14="http://schemas.microsoft.com/office/powerpoint/2010/main" val="2060788727"/>
-      </p:ext>
-    </p:extLst>
-  </p:cSld>
-  <p:clrMapOvr>
-    <a:masterClrMapping/>
-  </p:clrMapOvr>
-</p:sld>
-</file>
-
-<file path=ppt/slides/slide9.xml><?xml version="1.0" encoding="utf-8"?>
-<p:sld xmlns:a="http://schemas.openxmlformats.org/drawingml/2006/main" xmlns:r="http://schemas.openxmlformats.org/officeDocument/2006/relationships" xmlns:p="http://schemas.openxmlformats.org/presentationml/2006/main">
-  <p:cSld>
-    <p:spTree>
-      <p:nvGrpSpPr>
-        <p:cNvPr id="1" name="">
-          <a:extLst>
-            <a:ext uri="{FF2B5EF4-FFF2-40B4-BE49-F238E27FC236}">
-              <a16:creationId xmlns:a16="http://schemas.microsoft.com/office/drawing/2014/main" id="{7E38F23A-D6C9-B974-5B29-14986B854CAF}"/>
-            </a:ext>
-          </a:extLst>
-        </p:cNvPr>
-        <p:cNvGrpSpPr/>
-        <p:nvPr/>
-      </p:nvGrpSpPr>
-      <p:grpSpPr>
-        <a:xfrm>
-          <a:off x="0" y="0"/>
-          <a:ext cx="0" cy="0"/>
-          <a:chOff x="0" y="0"/>
-          <a:chExt cx="0" cy="0"/>
-        </a:xfrm>
-      </p:grpSpPr>
-    </p:spTree>
-    <p:extLst>
-      <p:ext uri="{BB962C8B-B14F-4D97-AF65-F5344CB8AC3E}">
-        <p14:creationId xmlns:p14="http://schemas.microsoft.com/office/powerpoint/2010/main" val="4169136817"/>
       </p:ext>
     </p:extLst>
   </p:cSld>

</xml_diff>